<commit_message>
docs: add slide 4 illustration to the working deck
</commit_message>
<xml_diff>
--- a/context/foundation/prezentacja/W_razie_W_HackYeah_2026_wersja_robocza.pptx
+++ b/context/foundation/prezentacja/W_razie_W_HackYeah_2026_wersja_robocza.pptx
@@ -3277,59 +3277,6 @@
       </p:sp>
       <p:sp>
         <p:nvSpPr>
-          <p:cNvPr id="8" name="Text 6"/>
-          <p:cNvSpPr/>
-          <p:nvPr/>
-        </p:nvSpPr>
-        <p:spPr>
-          <a:xfrm>
-            <a:off x="4883150" y="2503140"/>
-            <a:ext cx="2527300" cy="2019300"/>
-          </a:xfrm>
-          <a:prstGeom prst="roundRect">
-            <a:avLst>
-              <a:gd name="adj" fmla="val 8491"/>
-            </a:avLst>
-          </a:prstGeom>
-          <a:solidFill>
-            <a:srgbClr val="E3E7E9"/>
-          </a:solidFill>
-          <a:ln w="12700">
-            <a:solidFill>
-              <a:srgbClr val="2F3E45"/>
-            </a:solidFill>
-            <a:prstDash val="dash"/>
-          </a:ln>
-        </p:spPr>
-        <p:txBody>
-          <a:bodyPr wrap="square" lIns="127711" tIns="159334" rIns="127711" bIns="159334" rtlCol="0" anchor="ctr">
-            <a:normAutofit/>
-          </a:bodyPr>
-          <a:lstStyle/>
-          <a:p>
-            <a:pPr algn="ctr" indent="0" marL="0">
-              <a:lnSpc>
-                <a:spcPts val="1680"/>
-              </a:lnSpc>
-              <a:buNone/>
-            </a:pPr>
-            <a:r>
-              <a:rPr lang="en-US" sz="1200" dirty="0">
-                <a:solidFill>
-                  <a:srgbClr val="2F3E45"/>
-                </a:solidFill>
-                <a:latin typeface="Commissioner" pitchFamily="34" charset="0"/>
-                <a:ea typeface="Commissioner" pitchFamily="34" charset="-122"/>
-                <a:cs typeface="Commissioner" pitchFamily="34" charset="-120"/>
-              </a:rPr>
-              <a:t>[ilustracja: człowiek pod stosem informacji]</a:t>
-            </a:r>
-            <a:endParaRPr lang="en-US" sz="1200" dirty="0"/>
-          </a:p>
-        </p:txBody>
-      </p:sp>
-      <p:sp>
-        <p:nvSpPr>
           <p:cNvPr id="9" name="Text 7"/>
           <p:cNvSpPr/>
           <p:nvPr/>
@@ -3508,6 +3455,30 @@
           </a:p>
         </p:txBody>
       </p:sp>
+      <p:pic>
+        <p:nvPicPr>
+          <p:cNvPr id="1019" name="Image 1019" descr="Ilustracja: osoba pod stosem informacji"/>
+          <p:cNvPicPr>
+            <a:picLocks noChangeAspect="1"/>
+          </p:cNvPicPr>
+          <p:nvPr/>
+        </p:nvPicPr>
+        <p:blipFill>
+          <a:blip r:embed="rId3"/>
+          <a:stretch>
+            <a:fillRect/>
+          </a:stretch>
+        </p:blipFill>
+        <p:spPr>
+          <a:xfrm>
+            <a:off x="4979623" y="2351692"/>
+            <a:ext cx="2334353" cy="2322195"/>
+          </a:xfrm>
+          <a:prstGeom prst="rect">
+            <a:avLst/>
+          </a:prstGeom>
+        </p:spPr>
+      </p:pic>
     </p:spTree>
   </p:cSld>
   <p:clrMapOvr>

</xml_diff>

<commit_message>
docs: align deck visuals with the updated pitch brief
Amber allowed only as a key-phrase marker; screenshots retaken offline,
without device frames, large and cropped by the slide edge; icons on the
appendix slide.
</commit_message>
<xml_diff>
--- a/context/foundation/prezentacja/W_razie_W_HackYeah_2026_wersja_robocza.pptx
+++ b/context/foundation/prezentacja/W_razie_W_HackYeah_2026_wersja_robocza.pptx
@@ -3457,7 +3457,7 @@
       </p:sp>
       <p:pic>
         <p:nvPicPr>
-          <p:cNvPr id="1019" name="Image 1019" descr="Ilustracja: osoba pod stosem informacji"/>
+          <p:cNvPr id="1023" name="Image 1023" descr="Ilustracja: osoba pod stosem informacji"/>
           <p:cNvPicPr>
             <a:picLocks noChangeAspect="1"/>
           </p:cNvPicPr>
@@ -4555,53 +4555,9 @@
           </a:p>
         </p:txBody>
       </p:sp>
-      <p:sp>
-        <p:nvSpPr>
-          <p:cNvPr id="10" name="Text 8"/>
-          <p:cNvSpPr/>
-          <p:nvPr/>
-        </p:nvSpPr>
-        <p:spPr>
-          <a:xfrm>
-            <a:off x="10820400" y="6238280"/>
-            <a:ext cx="558800" cy="238720"/>
-          </a:xfrm>
-          <a:prstGeom prst="rect">
-            <a:avLst/>
-          </a:prstGeom>
-          <a:noFill/>
-          <a:ln/>
-        </p:spPr>
-        <p:txBody>
-          <a:bodyPr wrap="square" lIns="0" tIns="0" rIns="0" bIns="0" rtlCol="0" anchor="t">
-            <a:normAutofit/>
-          </a:bodyPr>
-          <a:lstStyle/>
-          <a:p>
-            <a:pPr algn="r" indent="0" marL="0">
-              <a:lnSpc>
-                <a:spcPts val="1680"/>
-              </a:lnSpc>
-              <a:buNone/>
-            </a:pPr>
-            <a:r>
-              <a:rPr lang="en-US" sz="1200" dirty="0">
-                <a:solidFill>
-                  <a:srgbClr val="E3E7E9"/>
-                </a:solidFill>
-                <a:latin typeface="Commissioner" pitchFamily="34" charset="0"/>
-                <a:ea typeface="Commissioner" pitchFamily="34" charset="-122"/>
-                <a:cs typeface="Commissioner" pitchFamily="34" charset="-120"/>
-              </a:rPr>
-              <a:t>6</a:t>
-            </a:r>
-            <a:endParaRPr lang="en-US" sz="1200" dirty="0"/>
-          </a:p>
-        </p:txBody>
-      </p:sp>
       <p:pic>
         <p:nvPicPr>
-          <p:cNvPr id="1015" name="Image 1015" descr="Zrzut ekranu aplikacji: przygotowanie-1-plan"/>
+          <p:cNvPr id="1015" name="Image 1015" descr="Zrzut ekranu aplikacji w trybie offline: przygotowanie-1-miejsca"/>
           <p:cNvPicPr>
             <a:picLocks noChangeAspect="1"/>
           </p:cNvPicPr>
@@ -4609,14 +4565,15 @@
         </p:nvPicPr>
         <p:blipFill>
           <a:blip r:embed="rId3"/>
+          <a:srcRect b="11265"/>
           <a:stretch>
             <a:fillRect/>
           </a:stretch>
         </p:blipFill>
         <p:spPr>
           <a:xfrm>
-            <a:off x="1123950" y="2292350"/>
-            <a:ext cx="1765300" cy="3710557"/>
+            <a:off x="1115568" y="2331720"/>
+            <a:ext cx="2240280" cy="4526280"/>
           </a:xfrm>
           <a:prstGeom prst="rect">
             <a:avLst/>
@@ -4625,7 +4582,7 @@
       </p:pic>
       <p:pic>
         <p:nvPicPr>
-          <p:cNvPr id="1016" name="Image 1016" descr="Zrzut ekranu aplikacji: przygotowanie-2-plecak"/>
+          <p:cNvPr id="1016" name="Image 1016" descr="Zrzut ekranu aplikacji w trybie offline: przygotowanie-2-plecak"/>
           <p:cNvPicPr>
             <a:picLocks noChangeAspect="1"/>
           </p:cNvPicPr>
@@ -4633,14 +4590,15 @@
         </p:nvPicPr>
         <p:blipFill>
           <a:blip r:embed="rId4"/>
+          <a:srcRect b="11265"/>
           <a:stretch>
             <a:fillRect/>
           </a:stretch>
         </p:blipFill>
         <p:spPr>
           <a:xfrm>
-            <a:off x="3155950" y="2292350"/>
-            <a:ext cx="1765300" cy="3710557"/>
+            <a:off x="3630168" y="2331720"/>
+            <a:ext cx="2240280" cy="4526280"/>
           </a:xfrm>
           <a:prstGeom prst="rect">
             <a:avLst/>
@@ -4649,7 +4607,7 @@
       </p:pic>
       <p:pic>
         <p:nvPicPr>
-          <p:cNvPr id="1017" name="Image 1017" descr="Zrzut ekranu aplikacji: kryzys-1-krok"/>
+          <p:cNvPr id="1017" name="Image 1017" descr="Zrzut ekranu aplikacji w trybie offline: kryzys-1-krok"/>
           <p:cNvPicPr>
             <a:picLocks noChangeAspect="1"/>
           </p:cNvPicPr>
@@ -4657,14 +4615,15 @@
         </p:nvPicPr>
         <p:blipFill>
           <a:blip r:embed="rId5"/>
+          <a:srcRect b="11265"/>
           <a:stretch>
             <a:fillRect/>
           </a:stretch>
         </p:blipFill>
         <p:spPr>
           <a:xfrm>
-            <a:off x="7016750" y="2292350"/>
-            <a:ext cx="1765300" cy="3710557"/>
+            <a:off x="7013448" y="2331720"/>
+            <a:ext cx="2240280" cy="4526280"/>
           </a:xfrm>
           <a:prstGeom prst="rect">
             <a:avLst/>
@@ -4673,7 +4632,7 @@
       </p:pic>
       <p:pic>
         <p:nvPicPr>
-          <p:cNvPr id="1018" name="Image 1018" descr="Zrzut ekranu aplikacji: kryzys-2-prowadzenie"/>
+          <p:cNvPr id="1018" name="Image 1018" descr="Zrzut ekranu aplikacji w trybie offline: kryzys-2-prowadzenie"/>
           <p:cNvPicPr>
             <a:picLocks noChangeAspect="1"/>
           </p:cNvPicPr>
@@ -4681,20 +4640,65 @@
         </p:nvPicPr>
         <p:blipFill>
           <a:blip r:embed="rId6"/>
+          <a:srcRect b="11265"/>
           <a:stretch>
             <a:fillRect/>
           </a:stretch>
         </p:blipFill>
         <p:spPr>
           <a:xfrm>
-            <a:off x="9048750" y="2292350"/>
-            <a:ext cx="1765300" cy="3710557"/>
+            <a:off x="9528048" y="2331720"/>
+            <a:ext cx="2240280" cy="4526280"/>
           </a:xfrm>
           <a:prstGeom prst="rect">
             <a:avLst/>
           </a:prstGeom>
         </p:spPr>
       </p:pic>
+      <p:sp>
+        <p:nvSpPr>
+          <p:cNvPr id="10" name="Text 8"/>
+          <p:cNvSpPr/>
+          <p:nvPr/>
+        </p:nvSpPr>
+        <p:spPr>
+          <a:xfrm>
+            <a:off x="10820400" y="6238280"/>
+            <a:ext cx="558800" cy="238720"/>
+          </a:xfrm>
+          <a:prstGeom prst="rect">
+            <a:avLst/>
+          </a:prstGeom>
+          <a:noFill/>
+          <a:ln/>
+        </p:spPr>
+        <p:txBody>
+          <a:bodyPr wrap="square" lIns="0" tIns="0" rIns="0" bIns="0" rtlCol="0" anchor="t">
+            <a:normAutofit/>
+          </a:bodyPr>
+          <a:lstStyle/>
+          <a:p>
+            <a:pPr algn="r" indent="0" marL="0">
+              <a:lnSpc>
+                <a:spcPts val="1680"/>
+              </a:lnSpc>
+              <a:buNone/>
+            </a:pPr>
+            <a:r>
+              <a:rPr lang="en-US" sz="1200" dirty="0">
+                <a:solidFill>
+                  <a:srgbClr val="E3E7E9"/>
+                </a:solidFill>
+                <a:latin typeface="Commissioner" pitchFamily="34" charset="0"/>
+                <a:ea typeface="Commissioner" pitchFamily="34" charset="-122"/>
+                <a:cs typeface="Commissioner" pitchFamily="34" charset="-120"/>
+              </a:rPr>
+              <a:t>6</a:t>
+            </a:r>
+            <a:endParaRPr lang="en-US" sz="1200" dirty="0"/>
+          </a:p>
+        </p:txBody>
+      </p:sp>
     </p:spTree>
   </p:cSld>
   <p:clrMapOvr>
@@ -6429,12 +6433,11 @@
               <a:gd name="adj" fmla="val 17742"/>
             </a:avLst>
           </a:prstGeom>
-          <a:noFill/>
-          <a:ln w="12700">
-            <a:solidFill>
-              <a:srgbClr val="536B75"/>
-            </a:solidFill>
-            <a:prstDash val="dash"/>
+          <a:solidFill>
+            <a:srgbClr val="E3E7E9"/>
+          </a:solidFill>
+          <a:ln>
+            <a:noFill/>
           </a:ln>
         </p:spPr>
       </p:sp>
@@ -6542,12 +6545,11 @@
               <a:gd name="adj" fmla="val 17742"/>
             </a:avLst>
           </a:prstGeom>
-          <a:noFill/>
-          <a:ln w="12700">
-            <a:solidFill>
-              <a:srgbClr val="536B75"/>
-            </a:solidFill>
-            <a:prstDash val="dash"/>
+          <a:solidFill>
+            <a:srgbClr val="E3E7E9"/>
+          </a:solidFill>
+          <a:ln>
+            <a:noFill/>
           </a:ln>
         </p:spPr>
       </p:sp>
@@ -6655,12 +6657,11 @@
               <a:gd name="adj" fmla="val 17742"/>
             </a:avLst>
           </a:prstGeom>
-          <a:noFill/>
-          <a:ln w="12700">
-            <a:solidFill>
-              <a:srgbClr val="536B75"/>
-            </a:solidFill>
-            <a:prstDash val="dash"/>
+          <a:solidFill>
+            <a:srgbClr val="E3E7E9"/>
+          </a:solidFill>
+          <a:ln>
+            <a:noFill/>
           </a:ln>
         </p:spPr>
       </p:sp>
@@ -6768,12 +6769,11 @@
               <a:gd name="adj" fmla="val 17742"/>
             </a:avLst>
           </a:prstGeom>
-          <a:noFill/>
-          <a:ln w="12700">
-            <a:solidFill>
-              <a:srgbClr val="536B75"/>
-            </a:solidFill>
-            <a:prstDash val="dash"/>
+          <a:solidFill>
+            <a:srgbClr val="E3E7E9"/>
+          </a:solidFill>
+          <a:ln>
+            <a:noFill/>
           </a:ln>
         </p:spPr>
       </p:sp>
@@ -6909,6 +6909,102 @@
           </a:p>
         </p:txBody>
       </p:sp>
+      <p:pic>
+        <p:nvPicPr>
+          <p:cNvPr id="1019" name="Image 1019" descr="Newspaper"/>
+          <p:cNvPicPr>
+            <a:picLocks noChangeAspect="1"/>
+          </p:cNvPicPr>
+          <p:nvPr/>
+        </p:nvPicPr>
+        <p:blipFill>
+          <a:blip r:embed="rId3"/>
+          <a:stretch>
+            <a:fillRect/>
+          </a:stretch>
+        </p:blipFill>
+        <p:spPr>
+          <a:xfrm>
+            <a:off x="897890" y="1791901"/>
+            <a:ext cx="236219" cy="236219"/>
+          </a:xfrm>
+          <a:prstGeom prst="rect">
+            <a:avLst/>
+          </a:prstGeom>
+        </p:spPr>
+      </p:pic>
+      <p:pic>
+        <p:nvPicPr>
+          <p:cNvPr id="1020" name="Image 1020" descr="PackageOpen"/>
+          <p:cNvPicPr>
+            <a:picLocks noChangeAspect="1"/>
+          </p:cNvPicPr>
+          <p:nvPr/>
+        </p:nvPicPr>
+        <p:blipFill>
+          <a:blip r:embed="rId4"/>
+          <a:stretch>
+            <a:fillRect/>
+          </a:stretch>
+        </p:blipFill>
+        <p:spPr>
+          <a:xfrm>
+            <a:off x="897890" y="2635161"/>
+            <a:ext cx="236219" cy="236219"/>
+          </a:xfrm>
+          <a:prstGeom prst="rect">
+            <a:avLst/>
+          </a:prstGeom>
+        </p:spPr>
+      </p:pic>
+      <p:pic>
+        <p:nvPicPr>
+          <p:cNvPr id="1021" name="Image 1021" descr="Library"/>
+          <p:cNvPicPr>
+            <a:picLocks noChangeAspect="1"/>
+          </p:cNvPicPr>
+          <p:nvPr/>
+        </p:nvPicPr>
+        <p:blipFill>
+          <a:blip r:embed="rId5"/>
+          <a:stretch>
+            <a:fillRect/>
+          </a:stretch>
+        </p:blipFill>
+        <p:spPr>
+          <a:xfrm>
+            <a:off x="897890" y="3478421"/>
+            <a:ext cx="236219" cy="236219"/>
+          </a:xfrm>
+          <a:prstGeom prst="rect">
+            <a:avLst/>
+          </a:prstGeom>
+        </p:spPr>
+      </p:pic>
+      <p:pic>
+        <p:nvPicPr>
+          <p:cNvPr id="1022" name="Image 1022" descr="Route"/>
+          <p:cNvPicPr>
+            <a:picLocks noChangeAspect="1"/>
+          </p:cNvPicPr>
+          <p:nvPr/>
+        </p:nvPicPr>
+        <p:blipFill>
+          <a:blip r:embed="rId6"/>
+          <a:stretch>
+            <a:fillRect/>
+          </a:stretch>
+        </p:blipFill>
+        <p:spPr>
+          <a:xfrm>
+            <a:off x="897890" y="4321681"/>
+            <a:ext cx="236219" cy="236219"/>
+          </a:xfrm>
+          <a:prstGeom prst="rect">
+            <a:avLst/>
+          </a:prstGeom>
+        </p:spPr>
+      </p:pic>
     </p:spTree>
   </p:cSld>
   <p:clrMapOvr>

</xml_diff>

<commit_message>
docs: redesign deck composition with illustrations and route motif
</commit_message>
<xml_diff>
--- a/context/foundation/prezentacja/W_razie_W_HackYeah_2026_wersja_robocza.pptx
+++ b/context/foundation/prezentacja/W_razie_W_HackYeah_2026_wersja_robocza.pptx
@@ -861,10 +861,27 @@
           <a:lstStyle/>
           <a:p>
             <a:r>
-              <a:rPr lang="en-US" dirty="0"/>
-              <a:t/>
-            </a:r>
-            <a:endParaRPr lang="en-US" dirty="0"/>
+              <a:rPr lang="pl-PL" dirty="0"/>
+              <a:t>Plan dla twojego domu: Odpowiadasz na kilka pytań, a aplikacja układa plan według wytycznych rządowych.</a:t>
+            </a:r>
+          </a:p>
+          <a:p>
+            <a:r>
+              <a:rPr lang="pl-PL" dirty="0"/>
+              <a:t>Cała rodzina w planie: Dodajesz domowników, żeby każdy wiedział, co ma robić.</a:t>
+            </a:r>
+          </a:p>
+          <a:p>
+            <a:r>
+              <a:rPr lang="pl-PL" dirty="0"/>
+              <a:t>Plecak i miejsca spotkań: Wiesz, co spakować, gdzie się spotkać i dokąd iść, gdy pierwsze miejsce odpada.</a:t>
+            </a:r>
+          </a:p>
+          <a:p>
+            <a:r>
+              <a:rPr lang="pl-PL" dirty="0"/>
+              <a:t>Tryb awaryjny: Gdy coś się dzieje, aplikacja prowadzi cię krok po kroku, także bez internetu.</a:t>
+            </a:r>
           </a:p>
         </p:txBody>
       </p:sp>
@@ -1821,6 +1838,28 @@
       </p:grpSpPr>
       <p:sp>
         <p:nvSpPr>
+          <p:cNvPr id="2001" name="Panel ilustracji"/>
+          <p:cNvSpPr/>
+          <p:nvPr/>
+        </p:nvSpPr>
+        <p:spPr>
+          <a:xfrm>
+            <a:off x="6903720" y="0"/>
+            <a:ext cx="5287975" cy="6858000"/>
+          </a:xfrm>
+          <a:prstGeom prst="rect">
+            <a:avLst/>
+          </a:prstGeom>
+          <a:solidFill>
+            <a:srgbClr val="E3E7E9"/>
+          </a:solidFill>
+          <a:ln>
+            <a:noFill/>
+          </a:ln>
+        </p:spPr>
+      </p:sp>
+      <p:sp>
+        <p:nvSpPr>
           <p:cNvPr id="2" name="Text 0"/>
           <p:cNvSpPr/>
           <p:nvPr/>
@@ -1828,7 +1867,7 @@
         <p:spPr>
           <a:xfrm>
             <a:off x="812800" y="609600"/>
-            <a:ext cx="10883392" cy="238720"/>
+            <a:ext cx="5760720" cy="238720"/>
           </a:xfrm>
           <a:prstGeom prst="rect">
             <a:avLst/>
@@ -1922,7 +1961,7 @@
         <p:spPr>
           <a:xfrm>
             <a:off x="2438400" y="2435870"/>
-            <a:ext cx="5719584" cy="1041400"/>
+            <a:ext cx="4297680" cy="1041400"/>
           </a:xfrm>
           <a:prstGeom prst="rect">
             <a:avLst/>
@@ -1966,7 +2005,7 @@
         <p:spPr>
           <a:xfrm>
             <a:off x="2438400" y="3553470"/>
-            <a:ext cx="4909310" cy="355600"/>
+            <a:ext cx="4206240" cy="355600"/>
           </a:xfrm>
           <a:prstGeom prst="rect">
             <a:avLst/>
@@ -2010,7 +2049,7 @@
         <p:spPr>
           <a:xfrm>
             <a:off x="812800" y="5496620"/>
-            <a:ext cx="10883392" cy="274290"/>
+            <a:ext cx="5760720" cy="274290"/>
           </a:xfrm>
           <a:prstGeom prst="rect">
             <a:avLst/>
@@ -2054,7 +2093,7 @@
         <p:spPr>
           <a:xfrm>
             <a:off x="812800" y="5796310"/>
-            <a:ext cx="10883392" cy="274290"/>
+            <a:ext cx="5760720" cy="274290"/>
           </a:xfrm>
           <a:prstGeom prst="rect">
             <a:avLst/>
@@ -2113,6 +2152,92 @@
           </a:prstGeom>
         </p:spPr>
       </p:pic>
+      <p:pic>
+        <p:nvPicPr>
+          <p:cNvPr id="2002" name="Ilustracja" descr="Ilustracja: rodzina w drzwiach domu"/>
+          <p:cNvPicPr>
+            <a:picLocks noChangeAspect="1"/>
+          </p:cNvPicPr>
+          <p:nvPr/>
+        </p:nvPicPr>
+        <p:blipFill>
+          <a:blip r:embed="rId4"/>
+          <a:stretch>
+            <a:fillRect/>
+          </a:stretch>
+        </p:blipFill>
+        <p:spPr>
+          <a:xfrm>
+            <a:off x="7082315" y="1097280"/>
+            <a:ext cx="4930786" cy="5760720"/>
+          </a:xfrm>
+          <a:prstGeom prst="rect">
+            <a:avLst/>
+          </a:prstGeom>
+        </p:spPr>
+      </p:pic>
+      <p:sp>
+        <p:nvSpPr>
+          <p:cNvPr id="2003" name="Ścieżka okładki"/>
+          <p:cNvSpPr/>
+          <p:nvPr/>
+        </p:nvSpPr>
+        <p:spPr>
+          <a:xfrm>
+            <a:off x="2514600" y="4389120"/>
+            <a:ext cx="4297680" cy="914400"/>
+          </a:xfrm>
+          <a:custGeom>
+            <a:avLst/>
+            <a:gdLst/>
+            <a:ahLst/>
+            <a:cxnLst/>
+            <a:rect l="0" t="0" r="r" b="b"/>
+            <a:pathLst>
+              <a:path w="4297680" h="914400">
+                <a:moveTo>
+                  <a:pt x="4297680" y="868680"/>
+                </a:moveTo>
+                <a:cubicBezTo>
+                  <a:pt x="2880360" y="914400"/>
+                  <a:pt x="1508760" y="45720"/>
+                  <a:pt x="0" y="0"/>
+                </a:cubicBezTo>
+              </a:path>
+            </a:pathLst>
+          </a:custGeom>
+          <a:noFill/>
+          <a:ln w="28575" cap="rnd">
+            <a:solidFill>
+              <a:srgbClr val="536B75"/>
+            </a:solidFill>
+            <a:prstDash val="dash"/>
+            <a:round/>
+          </a:ln>
+        </p:spPr>
+      </p:sp>
+      <p:sp>
+        <p:nvSpPr>
+          <p:cNvPr id="2004" name="Punkt"/>
+          <p:cNvSpPr/>
+          <p:nvPr/>
+        </p:nvSpPr>
+        <p:spPr>
+          <a:xfrm>
+            <a:off x="2441448" y="4315968"/>
+            <a:ext cx="146304" cy="146304"/>
+          </a:xfrm>
+          <a:prstGeom prst="ellipse">
+            <a:avLst/>
+          </a:prstGeom>
+          <a:solidFill>
+            <a:srgbClr val="536B75"/>
+          </a:solidFill>
+          <a:ln>
+            <a:noFill/>
+          </a:ln>
+        </p:spPr>
+      </p:sp>
     </p:spTree>
   </p:cSld>
   <p:clrMapOvr>
@@ -3457,7 +3582,7 @@
       </p:sp>
       <p:pic>
         <p:nvPicPr>
-          <p:cNvPr id="1023" name="Image 1023" descr="Ilustracja: osoba pod stosem informacji"/>
+          <p:cNvPr id="1019" name="Image 1019" descr="Ilustracja: osoba pod stosem informacji"/>
           <p:cNvPicPr>
             <a:picLocks noChangeAspect="1"/>
           </p:cNvPicPr>
@@ -3471,8 +3596,8 @@
         </p:blipFill>
         <p:spPr>
           <a:xfrm>
-            <a:off x="4979623" y="2351692"/>
-            <a:ext cx="2334353" cy="2322195"/>
+            <a:off x="4836957" y="2209770"/>
+            <a:ext cx="2619684" cy="2606040"/>
           </a:xfrm>
           <a:prstGeom prst="rect">
             <a:avLst/>
@@ -3678,38 +3803,14 @@
       </p:sp>
       <p:sp>
         <p:nvSpPr>
-          <p:cNvPr id="6" name="Shape 4"/>
-          <p:cNvSpPr/>
-          <p:nvPr/>
-        </p:nvSpPr>
-        <p:spPr>
-          <a:xfrm>
-            <a:off x="1079500" y="2466280"/>
-            <a:ext cx="393700" cy="393700"/>
-          </a:xfrm>
-          <a:prstGeom prst="roundRect">
-            <a:avLst>
-              <a:gd name="adj" fmla="val 17742"/>
-            </a:avLst>
-          </a:prstGeom>
-          <a:solidFill>
-            <a:srgbClr val="E3E7E9"/>
-          </a:solidFill>
-          <a:ln>
-            <a:noFill/>
-          </a:ln>
-        </p:spPr>
-      </p:sp>
-      <p:sp>
-        <p:nvSpPr>
           <p:cNvPr id="7" name="Text 5"/>
           <p:cNvSpPr/>
           <p:nvPr/>
         </p:nvSpPr>
         <p:spPr>
           <a:xfrm>
-            <a:off x="1073150" y="2993330"/>
-            <a:ext cx="2027555" cy="609600"/>
+            <a:off x="1072007" y="4260155"/>
+            <a:ext cx="1970786" cy="609600"/>
           </a:xfrm>
           <a:prstGeom prst="rect">
             <a:avLst/>
@@ -3741,50 +3842,6 @@
               <a:t>Plan dla twojego domu</a:t>
             </a:r>
             <a:endParaRPr lang="en-US" sz="2000" dirty="0"/>
-          </a:p>
-        </p:txBody>
-      </p:sp>
-      <p:sp>
-        <p:nvSpPr>
-          <p:cNvPr id="8" name="Text 6"/>
-          <p:cNvSpPr/>
-          <p:nvPr/>
-        </p:nvSpPr>
-        <p:spPr>
-          <a:xfrm>
-            <a:off x="1073150" y="3704530"/>
-            <a:ext cx="2027555" cy="1020961"/>
-          </a:xfrm>
-          <a:prstGeom prst="rect">
-            <a:avLst/>
-          </a:prstGeom>
-          <a:noFill/>
-          <a:ln/>
-        </p:spPr>
-        <p:txBody>
-          <a:bodyPr wrap="square" lIns="0" tIns="0" rIns="0" bIns="0" rtlCol="0" anchor="t">
-            <a:normAutofit/>
-          </a:bodyPr>
-          <a:lstStyle/>
-          <a:p>
-            <a:pPr algn="l" indent="0" marL="0">
-              <a:lnSpc>
-                <a:spcPts val="1960"/>
-              </a:lnSpc>
-              <a:buNone/>
-            </a:pPr>
-            <a:r>
-              <a:rPr lang="en-US" sz="1400" dirty="0">
-                <a:solidFill>
-                  <a:srgbClr val="202427"/>
-                </a:solidFill>
-                <a:latin typeface="Commissioner" pitchFamily="34" charset="0"/>
-                <a:ea typeface="Commissioner" pitchFamily="34" charset="-122"/>
-                <a:cs typeface="Commissioner" pitchFamily="34" charset="-120"/>
-              </a:rPr>
-              <a:t>Odpowiadasz na kilka pytań, a aplikacja układa plan według wytycznych rządowych.</a:t>
-            </a:r>
-            <a:endParaRPr lang="en-US" sz="1400" dirty="0"/>
           </a:p>
         </p:txBody>
       </p:sp>
@@ -3817,38 +3874,14 @@
       </p:sp>
       <p:sp>
         <p:nvSpPr>
-          <p:cNvPr id="10" name="Shape 8"/>
-          <p:cNvSpPr/>
-          <p:nvPr/>
-        </p:nvSpPr>
-        <p:spPr>
-          <a:xfrm>
-            <a:off x="3771900" y="2466280"/>
-            <a:ext cx="393700" cy="393700"/>
-          </a:xfrm>
-          <a:prstGeom prst="roundRect">
-            <a:avLst>
-              <a:gd name="adj" fmla="val 17742"/>
-            </a:avLst>
-          </a:prstGeom>
-          <a:solidFill>
-            <a:srgbClr val="E3E7E9"/>
-          </a:solidFill>
-          <a:ln>
-            <a:noFill/>
-          </a:ln>
-        </p:spPr>
-      </p:sp>
-      <p:sp>
-        <p:nvSpPr>
           <p:cNvPr id="11" name="Text 9"/>
           <p:cNvSpPr/>
           <p:nvPr/>
         </p:nvSpPr>
         <p:spPr>
           <a:xfrm>
-            <a:off x="3765550" y="2993330"/>
-            <a:ext cx="2027555" cy="609600"/>
+            <a:off x="3764407" y="4260155"/>
+            <a:ext cx="1970786" cy="609600"/>
           </a:xfrm>
           <a:prstGeom prst="rect">
             <a:avLst/>
@@ -3880,50 +3913,6 @@
               <a:t>Cała rodzina w planie</a:t>
             </a:r>
             <a:endParaRPr lang="en-US" sz="2000" dirty="0"/>
-          </a:p>
-        </p:txBody>
-      </p:sp>
-      <p:sp>
-        <p:nvSpPr>
-          <p:cNvPr id="12" name="Text 10"/>
-          <p:cNvSpPr/>
-          <p:nvPr/>
-        </p:nvSpPr>
-        <p:spPr>
-          <a:xfrm>
-            <a:off x="3765550" y="3704530"/>
-            <a:ext cx="2027555" cy="772071"/>
-          </a:xfrm>
-          <a:prstGeom prst="rect">
-            <a:avLst/>
-          </a:prstGeom>
-          <a:noFill/>
-          <a:ln/>
-        </p:spPr>
-        <p:txBody>
-          <a:bodyPr wrap="square" lIns="0" tIns="0" rIns="0" bIns="0" rtlCol="0" anchor="t">
-            <a:normAutofit/>
-          </a:bodyPr>
-          <a:lstStyle/>
-          <a:p>
-            <a:pPr algn="l" indent="0" marL="0">
-              <a:lnSpc>
-                <a:spcPts val="1960"/>
-              </a:lnSpc>
-              <a:buNone/>
-            </a:pPr>
-            <a:r>
-              <a:rPr lang="en-US" sz="1400" dirty="0">
-                <a:solidFill>
-                  <a:srgbClr val="202427"/>
-                </a:solidFill>
-                <a:latin typeface="Commissioner" pitchFamily="34" charset="0"/>
-                <a:ea typeface="Commissioner" pitchFamily="34" charset="-122"/>
-                <a:cs typeface="Commissioner" pitchFamily="34" charset="-120"/>
-              </a:rPr>
-              <a:t>Dodajesz domowników, żeby każdy wiedział, co ma robić.</a:t>
-            </a:r>
-            <a:endParaRPr lang="en-US" sz="1400" dirty="0"/>
           </a:p>
         </p:txBody>
       </p:sp>
@@ -3956,38 +3945,14 @@
       </p:sp>
       <p:sp>
         <p:nvSpPr>
-          <p:cNvPr id="14" name="Shape 12"/>
-          <p:cNvSpPr/>
-          <p:nvPr/>
-        </p:nvSpPr>
-        <p:spPr>
-          <a:xfrm>
-            <a:off x="6464300" y="2466280"/>
-            <a:ext cx="393700" cy="393700"/>
-          </a:xfrm>
-          <a:prstGeom prst="roundRect">
-            <a:avLst>
-              <a:gd name="adj" fmla="val 17742"/>
-            </a:avLst>
-          </a:prstGeom>
-          <a:solidFill>
-            <a:srgbClr val="E3E7E9"/>
-          </a:solidFill>
-          <a:ln>
-            <a:noFill/>
-          </a:ln>
-        </p:spPr>
-      </p:sp>
-      <p:sp>
-        <p:nvSpPr>
           <p:cNvPr id="15" name="Text 13"/>
           <p:cNvSpPr/>
           <p:nvPr/>
         </p:nvSpPr>
         <p:spPr>
           <a:xfrm>
-            <a:off x="6457950" y="2993330"/>
-            <a:ext cx="2027555" cy="609600"/>
+            <a:off x="6456807" y="4260155"/>
+            <a:ext cx="1970786" cy="609600"/>
           </a:xfrm>
           <a:prstGeom prst="rect">
             <a:avLst/>
@@ -4019,50 +3984,6 @@
               <a:t>Plecak i miejsca spotkań</a:t>
             </a:r>
             <a:endParaRPr lang="en-US" sz="2000" dirty="0"/>
-          </a:p>
-        </p:txBody>
-      </p:sp>
-      <p:sp>
-        <p:nvSpPr>
-          <p:cNvPr id="16" name="Text 14"/>
-          <p:cNvSpPr/>
-          <p:nvPr/>
-        </p:nvSpPr>
-        <p:spPr>
-          <a:xfrm>
-            <a:off x="6457950" y="3704530"/>
-            <a:ext cx="2027555" cy="1020961"/>
-          </a:xfrm>
-          <a:prstGeom prst="rect">
-            <a:avLst/>
-          </a:prstGeom>
-          <a:noFill/>
-          <a:ln/>
-        </p:spPr>
-        <p:txBody>
-          <a:bodyPr wrap="square" lIns="0" tIns="0" rIns="0" bIns="0" rtlCol="0" anchor="t">
-            <a:normAutofit/>
-          </a:bodyPr>
-          <a:lstStyle/>
-          <a:p>
-            <a:pPr algn="l" indent="0" marL="0">
-              <a:lnSpc>
-                <a:spcPts val="1960"/>
-              </a:lnSpc>
-              <a:buNone/>
-            </a:pPr>
-            <a:r>
-              <a:rPr lang="en-US" sz="1400" dirty="0">
-                <a:solidFill>
-                  <a:srgbClr val="202427"/>
-                </a:solidFill>
-                <a:latin typeface="Commissioner" pitchFamily="34" charset="0"/>
-                <a:ea typeface="Commissioner" pitchFamily="34" charset="-122"/>
-                <a:cs typeface="Commissioner" pitchFamily="34" charset="-120"/>
-              </a:rPr>
-              <a:t>Wiesz, co spakować, gdzie się spotkać i dokąd iść, gdy pierwsze miejsce odpada.</a:t>
-            </a:r>
-            <a:endParaRPr lang="en-US" sz="1400" dirty="0"/>
           </a:p>
         </p:txBody>
       </p:sp>
@@ -4095,38 +4016,14 @@
       </p:sp>
       <p:sp>
         <p:nvSpPr>
-          <p:cNvPr id="18" name="Shape 16"/>
-          <p:cNvSpPr/>
-          <p:nvPr/>
-        </p:nvSpPr>
-        <p:spPr>
-          <a:xfrm>
-            <a:off x="9156700" y="2466280"/>
-            <a:ext cx="393700" cy="393700"/>
-          </a:xfrm>
-          <a:prstGeom prst="roundRect">
-            <a:avLst>
-              <a:gd name="adj" fmla="val 17742"/>
-            </a:avLst>
-          </a:prstGeom>
-          <a:solidFill>
-            <a:srgbClr val="E3E7E9"/>
-          </a:solidFill>
-          <a:ln>
-            <a:noFill/>
-          </a:ln>
-        </p:spPr>
-      </p:sp>
-      <p:sp>
-        <p:nvSpPr>
           <p:cNvPr id="19" name="Text 17"/>
           <p:cNvSpPr/>
           <p:nvPr/>
         </p:nvSpPr>
         <p:spPr>
           <a:xfrm>
-            <a:off x="9150350" y="2993330"/>
-            <a:ext cx="2027555" cy="317500"/>
+            <a:off x="9149207" y="4260155"/>
+            <a:ext cx="1970786" cy="317500"/>
           </a:xfrm>
           <a:prstGeom prst="rect">
             <a:avLst/>
@@ -4158,50 +4055,6 @@
               <a:t>Tryb awaryjny</a:t>
             </a:r>
             <a:endParaRPr lang="en-US" sz="2000" dirty="0"/>
-          </a:p>
-        </p:txBody>
-      </p:sp>
-      <p:sp>
-        <p:nvSpPr>
-          <p:cNvPr id="20" name="Text 18"/>
-          <p:cNvSpPr/>
-          <p:nvPr/>
-        </p:nvSpPr>
-        <p:spPr>
-          <a:xfrm>
-            <a:off x="9150350" y="3412430"/>
-            <a:ext cx="2027555" cy="1020961"/>
-          </a:xfrm>
-          <a:prstGeom prst="rect">
-            <a:avLst/>
-          </a:prstGeom>
-          <a:noFill/>
-          <a:ln/>
-        </p:spPr>
-        <p:txBody>
-          <a:bodyPr wrap="square" lIns="0" tIns="0" rIns="0" bIns="0" rtlCol="0" anchor="t">
-            <a:normAutofit/>
-          </a:bodyPr>
-          <a:lstStyle/>
-          <a:p>
-            <a:pPr algn="l" indent="0" marL="0">
-              <a:lnSpc>
-                <a:spcPts val="1960"/>
-              </a:lnSpc>
-              <a:buNone/>
-            </a:pPr>
-            <a:r>
-              <a:rPr lang="en-US" sz="1400" dirty="0">
-                <a:solidFill>
-                  <a:srgbClr val="202427"/>
-                </a:solidFill>
-                <a:latin typeface="Commissioner" pitchFamily="34" charset="0"/>
-                <a:ea typeface="Commissioner" pitchFamily="34" charset="-122"/>
-                <a:cs typeface="Commissioner" pitchFamily="34" charset="-120"/>
-              </a:rPr>
-              <a:t>Gdy coś się dzieje, aplikacja prowadzi cię krok po kroku, także bez internetu.</a:t>
-            </a:r>
-            <a:endParaRPr lang="en-US" sz="1400" dirty="0"/>
           </a:p>
         </p:txBody>
       </p:sp>
@@ -4275,7 +4128,7 @@
       </p:pic>
       <p:pic>
         <p:nvPicPr>
-          <p:cNvPr id="1003" name="Image 1003" descr="House"/>
+          <p:cNvPr id="2005" name="Ilustracja" descr="Ilustracja: rodzina w drzwiach"/>
           <p:cNvPicPr>
             <a:picLocks noChangeAspect="1"/>
           </p:cNvPicPr>
@@ -4289,8 +4142,8 @@
         </p:blipFill>
         <p:spPr>
           <a:xfrm>
-            <a:off x="1158240" y="2545020"/>
-            <a:ext cx="236219" cy="236219"/>
+            <a:off x="1274736" y="2339915"/>
+            <a:ext cx="1565329" cy="1828800"/>
           </a:xfrm>
           <a:prstGeom prst="rect">
             <a:avLst/>
@@ -4299,7 +4152,7 @@
       </p:pic>
       <p:pic>
         <p:nvPicPr>
-          <p:cNvPr id="1004" name="Image 1004" descr="Users"/>
+          <p:cNvPr id="2006" name="Ilustracja" descr="Ilustracja: udostępnienie planu"/>
           <p:cNvPicPr>
             <a:picLocks noChangeAspect="1"/>
           </p:cNvPicPr>
@@ -4313,8 +4166,8 @@
         </p:blipFill>
         <p:spPr>
           <a:xfrm>
-            <a:off x="3850640" y="2545020"/>
-            <a:ext cx="236219" cy="236219"/>
+            <a:off x="3684480" y="2339915"/>
+            <a:ext cx="2130641" cy="1828800"/>
           </a:xfrm>
           <a:prstGeom prst="rect">
             <a:avLst/>
@@ -4323,7 +4176,7 @@
       </p:pic>
       <p:pic>
         <p:nvPicPr>
-          <p:cNvPr id="1005" name="Image 1005" descr="Backpack"/>
+          <p:cNvPr id="2007" name="Ilustracja" descr="Ilustracja: pakowanie plecaka"/>
           <p:cNvPicPr>
             <a:picLocks noChangeAspect="1"/>
           </p:cNvPicPr>
@@ -4337,8 +4190,8 @@
         </p:blipFill>
         <p:spPr>
           <a:xfrm>
-            <a:off x="6543040" y="2545020"/>
-            <a:ext cx="236219" cy="236219"/>
+            <a:off x="6347656" y="2339915"/>
+            <a:ext cx="2189087" cy="1828800"/>
           </a:xfrm>
           <a:prstGeom prst="rect">
             <a:avLst/>
@@ -4347,7 +4200,7 @@
       </p:pic>
       <p:pic>
         <p:nvPicPr>
-          <p:cNvPr id="1006" name="Image 1006" descr="Navigation"/>
+          <p:cNvPr id="2008" name="Ilustracja" descr="Ilustracja: prowadzenie do punktu"/>
           <p:cNvPicPr>
             <a:picLocks noChangeAspect="1"/>
           </p:cNvPicPr>
@@ -4361,14 +4214,140 @@
         </p:blipFill>
         <p:spPr>
           <a:xfrm>
-            <a:off x="9235440" y="2545020"/>
-            <a:ext cx="236219" cy="236219"/>
+            <a:off x="9030335" y="2519289"/>
+            <a:ext cx="2208530" cy="1470053"/>
           </a:xfrm>
           <a:prstGeom prst="rect">
             <a:avLst/>
           </a:prstGeom>
         </p:spPr>
       </p:pic>
+      <p:sp>
+        <p:nvSpPr>
+          <p:cNvPr id="2009" name="Droga funkcji"/>
+          <p:cNvSpPr/>
+          <p:nvPr/>
+        </p:nvSpPr>
+        <p:spPr>
+          <a:xfrm>
+            <a:off x="2057400" y="5341314"/>
+            <a:ext cx="8077200" cy="9144"/>
+          </a:xfrm>
+          <a:custGeom>
+            <a:avLst/>
+            <a:gdLst/>
+            <a:ahLst/>
+            <a:cxnLst/>
+            <a:rect l="0" t="0" r="r" b="b"/>
+            <a:pathLst>
+              <a:path w="8077200" h="9144">
+                <a:moveTo>
+                  <a:pt x="0" y="0"/>
+                </a:moveTo>
+                <a:lnTo>
+                  <a:pt x="8077200" y="0"/>
+                </a:lnTo>
+              </a:path>
+            </a:pathLst>
+          </a:custGeom>
+          <a:noFill/>
+          <a:ln w="28575" cap="rnd">
+            <a:solidFill>
+              <a:srgbClr val="536B75"/>
+            </a:solidFill>
+            <a:prstDash val="dash"/>
+            <a:round/>
+          </a:ln>
+        </p:spPr>
+      </p:sp>
+      <p:sp>
+        <p:nvSpPr>
+          <p:cNvPr id="2010" name="Punkt"/>
+          <p:cNvSpPr/>
+          <p:nvPr/>
+        </p:nvSpPr>
+        <p:spPr>
+          <a:xfrm>
+            <a:off x="1975104" y="5259018"/>
+            <a:ext cx="164592" cy="164592"/>
+          </a:xfrm>
+          <a:prstGeom prst="ellipse">
+            <a:avLst/>
+          </a:prstGeom>
+          <a:solidFill>
+            <a:srgbClr val="536B75"/>
+          </a:solidFill>
+          <a:ln>
+            <a:noFill/>
+          </a:ln>
+        </p:spPr>
+      </p:sp>
+      <p:sp>
+        <p:nvSpPr>
+          <p:cNvPr id="2011" name="Punkt"/>
+          <p:cNvSpPr/>
+          <p:nvPr/>
+        </p:nvSpPr>
+        <p:spPr>
+          <a:xfrm>
+            <a:off x="4667504" y="5259018"/>
+            <a:ext cx="164592" cy="164592"/>
+          </a:xfrm>
+          <a:prstGeom prst="ellipse">
+            <a:avLst/>
+          </a:prstGeom>
+          <a:solidFill>
+            <a:srgbClr val="536B75"/>
+          </a:solidFill>
+          <a:ln>
+            <a:noFill/>
+          </a:ln>
+        </p:spPr>
+      </p:sp>
+      <p:sp>
+        <p:nvSpPr>
+          <p:cNvPr id="2012" name="Punkt"/>
+          <p:cNvSpPr/>
+          <p:nvPr/>
+        </p:nvSpPr>
+        <p:spPr>
+          <a:xfrm>
+            <a:off x="7359904" y="5259018"/>
+            <a:ext cx="164592" cy="164592"/>
+          </a:xfrm>
+          <a:prstGeom prst="ellipse">
+            <a:avLst/>
+          </a:prstGeom>
+          <a:solidFill>
+            <a:srgbClr val="536B75"/>
+          </a:solidFill>
+          <a:ln>
+            <a:noFill/>
+          </a:ln>
+        </p:spPr>
+      </p:sp>
+      <p:sp>
+        <p:nvSpPr>
+          <p:cNvPr id="2013" name="Punkt"/>
+          <p:cNvSpPr/>
+          <p:nvPr/>
+        </p:nvSpPr>
+        <p:spPr>
+          <a:xfrm>
+            <a:off x="10052304" y="5259018"/>
+            <a:ext cx="164592" cy="164592"/>
+          </a:xfrm>
+          <a:prstGeom prst="ellipse">
+            <a:avLst/>
+          </a:prstGeom>
+          <a:solidFill>
+            <a:srgbClr val="536B75"/>
+          </a:solidFill>
+          <a:ln>
+            <a:noFill/>
+          </a:ln>
+        </p:spPr>
+      </p:sp>
     </p:spTree>
   </p:cSld>
   <p:clrMapOvr>
@@ -4557,7 +4536,7 @@
       </p:sp>
       <p:pic>
         <p:nvPicPr>
-          <p:cNvPr id="1015" name="Image 1015" descr="Zrzut ekranu aplikacji w trybie offline: przygotowanie-1-miejsca"/>
+          <p:cNvPr id="1011" name="Image 1011" descr="Zrzut ekranu aplikacji w trybie offline: przygotowanie-1-miejsca"/>
           <p:cNvPicPr>
             <a:picLocks noChangeAspect="1"/>
           </p:cNvPicPr>
@@ -4582,7 +4561,7 @@
       </p:pic>
       <p:pic>
         <p:nvPicPr>
-          <p:cNvPr id="1016" name="Image 1016" descr="Zrzut ekranu aplikacji w trybie offline: przygotowanie-2-plecak"/>
+          <p:cNvPr id="1012" name="Image 1012" descr="Zrzut ekranu aplikacji w trybie offline: przygotowanie-2-plecak"/>
           <p:cNvPicPr>
             <a:picLocks noChangeAspect="1"/>
           </p:cNvPicPr>
@@ -4607,7 +4586,7 @@
       </p:pic>
       <p:pic>
         <p:nvPicPr>
-          <p:cNvPr id="1017" name="Image 1017" descr="Zrzut ekranu aplikacji w trybie offline: kryzys-1-krok"/>
+          <p:cNvPr id="1013" name="Image 1013" descr="Zrzut ekranu aplikacji w trybie offline: kryzys-1-krok"/>
           <p:cNvPicPr>
             <a:picLocks noChangeAspect="1"/>
           </p:cNvPicPr>
@@ -4632,7 +4611,7 @@
       </p:pic>
       <p:pic>
         <p:nvPicPr>
-          <p:cNvPr id="1018" name="Image 1018" descr="Zrzut ekranu aplikacji w trybie offline: kryzys-2-prowadzenie"/>
+          <p:cNvPr id="1014" name="Image 1014" descr="Zrzut ekranu aplikacji w trybie offline: kryzys-2-prowadzenie"/>
           <p:cNvPicPr>
             <a:picLocks noChangeAspect="1"/>
           </p:cNvPicPr>
@@ -4655,6 +4634,104 @@
           </a:prstGeom>
         </p:spPr>
       </p:pic>
+      <p:sp>
+        <p:nvSpPr>
+          <p:cNvPr id="2014" name="Ścieżka przygotowanie"/>
+          <p:cNvSpPr/>
+          <p:nvPr/>
+        </p:nvSpPr>
+        <p:spPr>
+          <a:xfrm>
+            <a:off x="1115568" y="2231136"/>
+            <a:ext cx="4937760" cy="9144"/>
+          </a:xfrm>
+          <a:custGeom>
+            <a:avLst/>
+            <a:gdLst/>
+            <a:ahLst/>
+            <a:cxnLst/>
+            <a:rect l="0" t="0" r="r" b="b"/>
+            <a:pathLst>
+              <a:path w="4937760" h="9144">
+                <a:moveTo>
+                  <a:pt x="0" y="0"/>
+                </a:moveTo>
+                <a:lnTo>
+                  <a:pt x="4937760" y="0"/>
+                </a:lnTo>
+              </a:path>
+            </a:pathLst>
+          </a:custGeom>
+          <a:noFill/>
+          <a:ln w="28575" cap="rnd">
+            <a:solidFill>
+              <a:srgbClr val="536B75"/>
+            </a:solidFill>
+            <a:prstDash val="dash"/>
+            <a:round/>
+          </a:ln>
+        </p:spPr>
+      </p:sp>
+      <p:sp>
+        <p:nvSpPr>
+          <p:cNvPr id="2015" name="Ścieżka kryzys"/>
+          <p:cNvSpPr/>
+          <p:nvPr/>
+        </p:nvSpPr>
+        <p:spPr>
+          <a:xfrm>
+            <a:off x="6144768" y="2231136"/>
+            <a:ext cx="5623560" cy="9144"/>
+          </a:xfrm>
+          <a:custGeom>
+            <a:avLst/>
+            <a:gdLst/>
+            <a:ahLst/>
+            <a:cxnLst/>
+            <a:rect l="0" t="0" r="r" b="b"/>
+            <a:pathLst>
+              <a:path w="5623560" h="9144">
+                <a:moveTo>
+                  <a:pt x="0" y="0"/>
+                </a:moveTo>
+                <a:lnTo>
+                  <a:pt x="5623560" y="0"/>
+                </a:lnTo>
+              </a:path>
+            </a:pathLst>
+          </a:custGeom>
+          <a:noFill/>
+          <a:ln w="28575" cap="rnd">
+            <a:solidFill>
+              <a:srgbClr val="F2C15C"/>
+            </a:solidFill>
+            <a:prstDash val="dash"/>
+            <a:round/>
+          </a:ln>
+        </p:spPr>
+      </p:sp>
+      <p:sp>
+        <p:nvSpPr>
+          <p:cNvPr id="2016" name="Punkt"/>
+          <p:cNvSpPr/>
+          <p:nvPr/>
+        </p:nvSpPr>
+        <p:spPr>
+          <a:xfrm>
+            <a:off x="11695176" y="2157984"/>
+            <a:ext cx="146304" cy="146304"/>
+          </a:xfrm>
+          <a:prstGeom prst="ellipse">
+            <a:avLst/>
+          </a:prstGeom>
+          <a:solidFill>
+            <a:srgbClr val="F2C15C"/>
+          </a:solidFill>
+          <a:ln>
+            <a:noFill/>
+          </a:ln>
+        </p:spPr>
+      </p:sp>
       <p:sp>
         <p:nvSpPr>
           <p:cNvPr id="10" name="Text 8"/>
@@ -4813,7 +4890,7 @@
         <p:spPr>
           <a:xfrm>
             <a:off x="1079500" y="1683990"/>
-            <a:ext cx="393700" cy="393700"/>
+            <a:ext cx="585216" cy="585216"/>
           </a:xfrm>
           <a:prstGeom prst="roundRect">
             <a:avLst>
@@ -4836,7 +4913,7 @@
         </p:nvSpPr>
         <p:spPr>
           <a:xfrm>
-            <a:off x="1073150" y="2211040"/>
+            <a:off x="1073150" y="2402556"/>
             <a:ext cx="2027555" cy="901700"/>
           </a:xfrm>
           <a:prstGeom prst="rect">
@@ -4880,7 +4957,7 @@
         </p:nvSpPr>
         <p:spPr>
           <a:xfrm>
-            <a:off x="1073150" y="3214340"/>
+            <a:off x="1073150" y="3405856"/>
             <a:ext cx="2027555" cy="1020961"/>
           </a:xfrm>
           <a:prstGeom prst="rect">
@@ -4952,7 +5029,7 @@
         <p:spPr>
           <a:xfrm>
             <a:off x="3771900" y="1683990"/>
-            <a:ext cx="393700" cy="393700"/>
+            <a:ext cx="585216" cy="585216"/>
           </a:xfrm>
           <a:prstGeom prst="roundRect">
             <a:avLst>
@@ -4975,7 +5052,7 @@
         </p:nvSpPr>
         <p:spPr>
           <a:xfrm>
-            <a:off x="3765550" y="2211040"/>
+            <a:off x="3765550" y="2402556"/>
             <a:ext cx="2027555" cy="609600"/>
           </a:xfrm>
           <a:prstGeom prst="rect">
@@ -5019,7 +5096,7 @@
         </p:nvSpPr>
         <p:spPr>
           <a:xfrm>
-            <a:off x="3765550" y="2922240"/>
+            <a:off x="3765550" y="3113756"/>
             <a:ext cx="2027555" cy="1020961"/>
           </a:xfrm>
           <a:prstGeom prst="rect">
@@ -5091,7 +5168,7 @@
         <p:spPr>
           <a:xfrm>
             <a:off x="6464300" y="1683990"/>
-            <a:ext cx="393700" cy="393700"/>
+            <a:ext cx="585216" cy="585216"/>
           </a:xfrm>
           <a:prstGeom prst="roundRect">
             <a:avLst>
@@ -5114,7 +5191,7 @@
         </p:nvSpPr>
         <p:spPr>
           <a:xfrm>
-            <a:off x="6457950" y="2211040"/>
+            <a:off x="6457950" y="2402556"/>
             <a:ext cx="2027555" cy="609600"/>
           </a:xfrm>
           <a:prstGeom prst="rect">
@@ -5158,7 +5235,7 @@
         </p:nvSpPr>
         <p:spPr>
           <a:xfrm>
-            <a:off x="6457950" y="2922240"/>
+            <a:off x="6457950" y="3113756"/>
             <a:ext cx="2027555" cy="772071"/>
           </a:xfrm>
           <a:prstGeom prst="rect">
@@ -5230,7 +5307,7 @@
         <p:spPr>
           <a:xfrm>
             <a:off x="9156700" y="1683990"/>
-            <a:ext cx="393700" cy="393700"/>
+            <a:ext cx="585216" cy="585216"/>
           </a:xfrm>
           <a:prstGeom prst="roundRect">
             <a:avLst>
@@ -5253,7 +5330,7 @@
         </p:nvSpPr>
         <p:spPr>
           <a:xfrm>
-            <a:off x="9150350" y="2211040"/>
+            <a:off x="9150350" y="2402556"/>
             <a:ext cx="2027555" cy="317500"/>
           </a:xfrm>
           <a:prstGeom prst="rect">
@@ -5297,7 +5374,7 @@
         </p:nvSpPr>
         <p:spPr>
           <a:xfrm>
-            <a:off x="9150350" y="2630140"/>
+            <a:off x="9150350" y="2821656"/>
             <a:ext cx="2027555" cy="1020961"/>
           </a:xfrm>
           <a:prstGeom prst="rect">
@@ -5427,7 +5504,7 @@
       </p:sp>
       <p:pic>
         <p:nvPicPr>
-          <p:cNvPr id="1007" name="Image 1007" descr="ListChecks"/>
+          <p:cNvPr id="1003" name="Image 1003" descr="ListChecks"/>
           <p:cNvPicPr>
             <a:picLocks noChangeAspect="1"/>
           </p:cNvPicPr>
@@ -5441,8 +5518,8 @@
         </p:blipFill>
         <p:spPr>
           <a:xfrm>
-            <a:off x="1158240" y="1762730"/>
-            <a:ext cx="236219" cy="236219"/>
+            <a:off x="1196543" y="1801033"/>
+            <a:ext cx="351130" cy="351130"/>
           </a:xfrm>
           <a:prstGeom prst="rect">
             <a:avLst/>
@@ -5451,7 +5528,7 @@
       </p:pic>
       <p:pic>
         <p:nvPicPr>
-          <p:cNvPr id="1008" name="Image 1008" descr="Footprints"/>
+          <p:cNvPr id="1004" name="Image 1004" descr="Footprints"/>
           <p:cNvPicPr>
             <a:picLocks noChangeAspect="1"/>
           </p:cNvPicPr>
@@ -5465,8 +5542,8 @@
         </p:blipFill>
         <p:spPr>
           <a:xfrm>
-            <a:off x="3850640" y="1762730"/>
-            <a:ext cx="236219" cy="236219"/>
+            <a:off x="3888943" y="1801033"/>
+            <a:ext cx="351130" cy="351130"/>
           </a:xfrm>
           <a:prstGeom prst="rect">
             <a:avLst/>
@@ -5475,7 +5552,7 @@
       </p:pic>
       <p:pic>
         <p:nvPicPr>
-          <p:cNvPr id="1009" name="Image 1009" descr="WifiOff"/>
+          <p:cNvPr id="1005" name="Image 1005" descr="WifiOff"/>
           <p:cNvPicPr>
             <a:picLocks noChangeAspect="1"/>
           </p:cNvPicPr>
@@ -5489,8 +5566,8 @@
         </p:blipFill>
         <p:spPr>
           <a:xfrm>
-            <a:off x="6543040" y="1762730"/>
-            <a:ext cx="236219" cy="236219"/>
+            <a:off x="6581343" y="1801033"/>
+            <a:ext cx="351130" cy="351130"/>
           </a:xfrm>
           <a:prstGeom prst="rect">
             <a:avLst/>
@@ -5499,7 +5576,7 @@
       </p:pic>
       <p:pic>
         <p:nvPicPr>
-          <p:cNvPr id="1010" name="Image 1010" descr="UserX"/>
+          <p:cNvPr id="1006" name="Image 1006" descr="UserX"/>
           <p:cNvPicPr>
             <a:picLocks noChangeAspect="1"/>
           </p:cNvPicPr>
@@ -5513,8 +5590,8 @@
         </p:blipFill>
         <p:spPr>
           <a:xfrm>
-            <a:off x="9235440" y="1762730"/>
-            <a:ext cx="236219" cy="236219"/>
+            <a:off x="9273743" y="1801033"/>
+            <a:ext cx="351130" cy="351130"/>
           </a:xfrm>
           <a:prstGeom prst="rect">
             <a:avLst/>
@@ -5635,7 +5712,7 @@
         <p:spPr>
           <a:xfrm>
             <a:off x="1079500" y="1683990"/>
-            <a:ext cx="393700" cy="393700"/>
+            <a:ext cx="585216" cy="585216"/>
           </a:xfrm>
           <a:prstGeom prst="roundRect">
             <a:avLst>
@@ -5658,7 +5735,7 @@
         </p:nvSpPr>
         <p:spPr>
           <a:xfrm>
-            <a:off x="1073150" y="2211040"/>
+            <a:off x="1073150" y="2402556"/>
             <a:ext cx="2027555" cy="609600"/>
           </a:xfrm>
           <a:prstGeom prst="rect">
@@ -5702,7 +5779,7 @@
         </p:nvSpPr>
         <p:spPr>
           <a:xfrm>
-            <a:off x="1073150" y="2922240"/>
+            <a:off x="1073150" y="3113756"/>
             <a:ext cx="2027555" cy="1020961"/>
           </a:xfrm>
           <a:prstGeom prst="rect">
@@ -5774,7 +5851,7 @@
         <p:spPr>
           <a:xfrm>
             <a:off x="3771900" y="1683990"/>
-            <a:ext cx="393700" cy="393700"/>
+            <a:ext cx="585216" cy="585216"/>
           </a:xfrm>
           <a:prstGeom prst="roundRect">
             <a:avLst>
@@ -5797,7 +5874,7 @@
         </p:nvSpPr>
         <p:spPr>
           <a:xfrm>
-            <a:off x="3765550" y="2211040"/>
+            <a:off x="3765550" y="2402556"/>
             <a:ext cx="2027555" cy="317500"/>
           </a:xfrm>
           <a:prstGeom prst="rect">
@@ -5841,7 +5918,7 @@
         </p:nvSpPr>
         <p:spPr>
           <a:xfrm>
-            <a:off x="3765550" y="2630140"/>
+            <a:off x="3765550" y="2821656"/>
             <a:ext cx="2027555" cy="1020961"/>
           </a:xfrm>
           <a:prstGeom prst="rect">
@@ -5913,7 +5990,7 @@
         <p:spPr>
           <a:xfrm>
             <a:off x="6464300" y="1683990"/>
-            <a:ext cx="393700" cy="393700"/>
+            <a:ext cx="585216" cy="585216"/>
           </a:xfrm>
           <a:prstGeom prst="roundRect">
             <a:avLst>
@@ -5936,7 +6013,7 @@
         </p:nvSpPr>
         <p:spPr>
           <a:xfrm>
-            <a:off x="6457950" y="2211040"/>
+            <a:off x="6457950" y="2402556"/>
             <a:ext cx="2027555" cy="317500"/>
           </a:xfrm>
           <a:prstGeom prst="rect">
@@ -5980,7 +6057,7 @@
         </p:nvSpPr>
         <p:spPr>
           <a:xfrm>
-            <a:off x="6457950" y="2630140"/>
+            <a:off x="6457950" y="2821656"/>
             <a:ext cx="2027555" cy="772071"/>
           </a:xfrm>
           <a:prstGeom prst="rect">
@@ -6052,7 +6129,7 @@
         <p:spPr>
           <a:xfrm>
             <a:off x="9156700" y="1683990"/>
-            <a:ext cx="393700" cy="393700"/>
+            <a:ext cx="585216" cy="585216"/>
           </a:xfrm>
           <a:prstGeom prst="roundRect">
             <a:avLst>
@@ -6075,7 +6152,7 @@
         </p:nvSpPr>
         <p:spPr>
           <a:xfrm>
-            <a:off x="9150350" y="2211040"/>
+            <a:off x="9150350" y="2402556"/>
             <a:ext cx="2027555" cy="609600"/>
           </a:xfrm>
           <a:prstGeom prst="rect">
@@ -6119,7 +6196,7 @@
         </p:nvSpPr>
         <p:spPr>
           <a:xfrm>
-            <a:off x="9150350" y="2922240"/>
+            <a:off x="9150350" y="3113756"/>
             <a:ext cx="2027555" cy="772071"/>
           </a:xfrm>
           <a:prstGeom prst="rect">
@@ -6201,7 +6278,7 @@
       </p:sp>
       <p:pic>
         <p:nvPicPr>
-          <p:cNvPr id="1011" name="Image 1011" descr="MapPin"/>
+          <p:cNvPr id="1007" name="Image 1007" descr="MapPin"/>
           <p:cNvPicPr>
             <a:picLocks noChangeAspect="1"/>
           </p:cNvPicPr>
@@ -6215,8 +6292,8 @@
         </p:blipFill>
         <p:spPr>
           <a:xfrm>
-            <a:off x="1158240" y="1762730"/>
-            <a:ext cx="236219" cy="236219"/>
+            <a:off x="1196543" y="1801033"/>
+            <a:ext cx="351130" cy="351130"/>
           </a:xfrm>
           <a:prstGeom prst="rect">
             <a:avLst/>
@@ -6225,7 +6302,7 @@
       </p:pic>
       <p:pic>
         <p:nvPicPr>
-          <p:cNvPr id="1012" name="Image 1012" descr="Share2"/>
+          <p:cNvPr id="1008" name="Image 1008" descr="Share2"/>
           <p:cNvPicPr>
             <a:picLocks noChangeAspect="1"/>
           </p:cNvPicPr>
@@ -6239,8 +6316,8 @@
         </p:blipFill>
         <p:spPr>
           <a:xfrm>
-            <a:off x="3850640" y="1762730"/>
-            <a:ext cx="236219" cy="236219"/>
+            <a:off x="3888943" y="1801033"/>
+            <a:ext cx="351130" cy="351130"/>
           </a:xfrm>
           <a:prstGeom prst="rect">
             <a:avLst/>
@@ -6249,7 +6326,7 @@
       </p:pic>
       <p:pic>
         <p:nvPicPr>
-          <p:cNvPr id="1013" name="Image 1013" descr="BellRing"/>
+          <p:cNvPr id="1009" name="Image 1009" descr="BellRing"/>
           <p:cNvPicPr>
             <a:picLocks noChangeAspect="1"/>
           </p:cNvPicPr>
@@ -6263,8 +6340,8 @@
         </p:blipFill>
         <p:spPr>
           <a:xfrm>
-            <a:off x="6543040" y="1762730"/>
-            <a:ext cx="236219" cy="236219"/>
+            <a:off x="6581343" y="1801033"/>
+            <a:ext cx="351130" cy="351130"/>
           </a:xfrm>
           <a:prstGeom prst="rect">
             <a:avLst/>
@@ -6273,7 +6350,7 @@
       </p:pic>
       <p:pic>
         <p:nvPicPr>
-          <p:cNvPr id="1014" name="Image 1014" descr="CloudRain"/>
+          <p:cNvPr id="1010" name="Image 1010" descr="CloudRain"/>
           <p:cNvPicPr>
             <a:picLocks noChangeAspect="1"/>
           </p:cNvPicPr>
@@ -6287,8 +6364,8 @@
         </p:blipFill>
         <p:spPr>
           <a:xfrm>
-            <a:off x="9235440" y="1762730"/>
-            <a:ext cx="236219" cy="236219"/>
+            <a:off x="9273743" y="1801033"/>
+            <a:ext cx="351130" cy="351130"/>
           </a:xfrm>
           <a:prstGeom prst="rect">
             <a:avLst/>
@@ -6635,7 +6712,7 @@
                 <a:ea typeface="Commissioner" pitchFamily="34" charset="-122"/>
                 <a:cs typeface="Commissioner" pitchFamily="34" charset="-120"/>
               </a:rPr>
-              <a:t>77% badanych nie przygotowuje się w żaden sposób na ewentualność wojny (SW Research dla Onetu, marzec 2025).</a:t>
+              <a:t>77% badanych w żaden sposób nie przygotowuje się na wojnę (SW Research dla Onetu, 2025).</a:t>
             </a:r>
             <a:endParaRPr lang="en-US" sz="1600" dirty="0"/>
           </a:p>
@@ -6911,7 +6988,7 @@
       </p:sp>
       <p:pic>
         <p:nvPicPr>
-          <p:cNvPr id="1019" name="Image 1019" descr="Newspaper"/>
+          <p:cNvPr id="1015" name="Image 1015" descr="Newspaper"/>
           <p:cNvPicPr>
             <a:picLocks noChangeAspect="1"/>
           </p:cNvPicPr>
@@ -6935,7 +7012,7 @@
       </p:pic>
       <p:pic>
         <p:nvPicPr>
-          <p:cNvPr id="1020" name="Image 1020" descr="PackageOpen"/>
+          <p:cNvPr id="1016" name="Image 1016" descr="PackageOpen"/>
           <p:cNvPicPr>
             <a:picLocks noChangeAspect="1"/>
           </p:cNvPicPr>
@@ -6959,7 +7036,7 @@
       </p:pic>
       <p:pic>
         <p:nvPicPr>
-          <p:cNvPr id="1021" name="Image 1021" descr="Library"/>
+          <p:cNvPr id="1017" name="Image 1017" descr="Library"/>
           <p:cNvPicPr>
             <a:picLocks noChangeAspect="1"/>
           </p:cNvPicPr>
@@ -6983,7 +7060,7 @@
       </p:pic>
       <p:pic>
         <p:nvPicPr>
-          <p:cNvPr id="1022" name="Image 1022" descr="Route"/>
+          <p:cNvPr id="1018" name="Image 1018" descr="Route"/>
           <p:cNvPicPr>
             <a:picLocks noChangeAspect="1"/>
           </p:cNvPicPr>

</xml_diff>